<commit_message>
Chuẩn hóa font theme của 8 deck về Cambria/Calibri
Theme mặc định do PptxGenJS sinh ra vẫn khai Calibri Light và các font
Nhật/Hàn/Trung, không khớp hệ thống thiết kế và không dùng cho tiếng Việt.
Sau khi sửa, kiểm định pptx_delivery_check của ppt-master cho kết quả
passed, 0 lỗi 0 cảnh báo trên cả 8 tệp; slide mới tạo trong PowerPoint
sẽ kế thừa đúng Cambria cho tiêu đề và Calibri cho nội dung.
</commit_message>
<xml_diff>
--- a/practice/bai-1-the-thuc.pptx
+++ b/practice/bai-1-the-thuc.pptx
@@ -8614,108 +8614,14 @@
     </a:clrScheme>
     <a:fontScheme name="Office">
       <a:majorFont>
-        <a:latin typeface="Calibri Light" panose="020F0302020204030204"/>
-        <a:ea typeface=""/>
-        <a:cs typeface=""/>
-        <a:font script="Jpan" typeface="游ゴシック Light"/>
-        <a:font script="Hang" typeface="맑은 고딕"/>
-        <a:font script="Hans" typeface="等线 Light"/>
-        <a:font script="Hant" typeface="新細明體"/>
-        <a:font script="Arab" typeface="Times New Roman"/>
-        <a:font script="Hebr" typeface="Times New Roman"/>
-        <a:font script="Thai" typeface="Angsana New"/>
-        <a:font script="Ethi" typeface="Nyala"/>
-        <a:font script="Beng" typeface="Vrinda"/>
-        <a:font script="Gujr" typeface="Shruti"/>
-        <a:font script="Khmr" typeface="MoolBoran"/>
-        <a:font script="Knda" typeface="Tunga"/>
-        <a:font script="Guru" typeface="Raavi"/>
-        <a:font script="Cans" typeface="Euphemia"/>
-        <a:font script="Cher" typeface="Plantagenet Cherokee"/>
-        <a:font script="Yiii" typeface="Microsoft Yi Baiti"/>
-        <a:font script="Tibt" typeface="Microsoft Himalaya"/>
-        <a:font script="Thaa" typeface="MV Boli"/>
-        <a:font script="Deva" typeface="Mangal"/>
-        <a:font script="Telu" typeface="Gautami"/>
-        <a:font script="Taml" typeface="Latha"/>
-        <a:font script="Syrc" typeface="Estrangelo Edessa"/>
-        <a:font script="Orya" typeface="Kalinga"/>
-        <a:font script="Mlym" typeface="Kartika"/>
-        <a:font script="Laoo" typeface="DokChampa"/>
-        <a:font script="Sinh" typeface="Iskoola Pota"/>
-        <a:font script="Mong" typeface="Mongolian Baiti"/>
-        <a:font script="Viet" typeface="Times New Roman"/>
-        <a:font script="Uigh" typeface="Microsoft Uighur"/>
-        <a:font script="Geor" typeface="Sylfaen"/>
-        <a:font script="Armn" typeface="Arial"/>
-        <a:font script="Bugi" typeface="Leelawadee UI"/>
-        <a:font script="Bopo" typeface="Microsoft JhengHei"/>
-        <a:font script="Java" typeface="Javanese Text"/>
-        <a:font script="Lisu" typeface="Segoe UI"/>
-        <a:font script="Mymr" typeface="Myanmar Text"/>
-        <a:font script="Nkoo" typeface="Ebrima"/>
-        <a:font script="Olck" typeface="Nirmala UI"/>
-        <a:font script="Osma" typeface="Ebrima"/>
-        <a:font script="Phag" typeface="Phagspa"/>
-        <a:font script="Syrn" typeface="Estrangelo Edessa"/>
-        <a:font script="Syrj" typeface="Estrangelo Edessa"/>
-        <a:font script="Syre" typeface="Estrangelo Edessa"/>
-        <a:font script="Sora" typeface="Nirmala UI"/>
-        <a:font script="Tale" typeface="Microsoft Tai Le"/>
-        <a:font script="Talu" typeface="Microsoft New Tai Lue"/>
-        <a:font script="Tfng" typeface="Ebrima"/>
+        <a:latin typeface="Cambria" panose="020F0302020204030204"/>
+        <a:ea typeface="Cambria"/>
+        <a:cs typeface="Cambria"/>
       </a:majorFont>
       <a:minorFont>
         <a:latin typeface="Calibri" panose="020F0502020204030204"/>
-        <a:ea typeface=""/>
-        <a:cs typeface=""/>
-        <a:font script="Jpan" typeface="游ゴシック"/>
-        <a:font script="Hang" typeface="맑은 고딕"/>
-        <a:font script="Hans" typeface="等线"/>
-        <a:font script="Hant" typeface="新細明體"/>
-        <a:font script="Arab" typeface="Arial"/>
-        <a:font script="Hebr" typeface="Arial"/>
-        <a:font script="Thai" typeface="Cordia New"/>
-        <a:font script="Ethi" typeface="Nyala"/>
-        <a:font script="Beng" typeface="Vrinda"/>
-        <a:font script="Gujr" typeface="Shruti"/>
-        <a:font script="Khmr" typeface="DaunPenh"/>
-        <a:font script="Knda" typeface="Tunga"/>
-        <a:font script="Guru" typeface="Raavi"/>
-        <a:font script="Cans" typeface="Euphemia"/>
-        <a:font script="Cher" typeface="Plantagenet Cherokee"/>
-        <a:font script="Yiii" typeface="Microsoft Yi Baiti"/>
-        <a:font script="Tibt" typeface="Microsoft Himalaya"/>
-        <a:font script="Thaa" typeface="MV Boli"/>
-        <a:font script="Deva" typeface="Mangal"/>
-        <a:font script="Telu" typeface="Gautami"/>
-        <a:font script="Taml" typeface="Latha"/>
-        <a:font script="Syrc" typeface="Estrangelo Edessa"/>
-        <a:font script="Orya" typeface="Kalinga"/>
-        <a:font script="Mlym" typeface="Kartika"/>
-        <a:font script="Laoo" typeface="DokChampa"/>
-        <a:font script="Sinh" typeface="Iskoola Pota"/>
-        <a:font script="Mong" typeface="Mongolian Baiti"/>
-        <a:font script="Viet" typeface="Arial"/>
-        <a:font script="Uigh" typeface="Microsoft Uighur"/>
-        <a:font script="Geor" typeface="Sylfaen"/>
-        <a:font script="Armn" typeface="Arial"/>
-        <a:font script="Bugi" typeface="Leelawadee UI"/>
-        <a:font script="Bopo" typeface="Microsoft JhengHei"/>
-        <a:font script="Java" typeface="Javanese Text"/>
-        <a:font script="Lisu" typeface="Segoe UI"/>
-        <a:font script="Mymr" typeface="Myanmar Text"/>
-        <a:font script="Nkoo" typeface="Ebrima"/>
-        <a:font script="Olck" typeface="Nirmala UI"/>
-        <a:font script="Osma" typeface="Ebrima"/>
-        <a:font script="Phag" typeface="Phagspa"/>
-        <a:font script="Syrn" typeface="Estrangelo Edessa"/>
-        <a:font script="Syrj" typeface="Estrangelo Edessa"/>
-        <a:font script="Syre" typeface="Estrangelo Edessa"/>
-        <a:font script="Sora" typeface="Nirmala UI"/>
-        <a:font script="Tale" typeface="Microsoft Tai Le"/>
-        <a:font script="Talu" typeface="Microsoft New Tai Lue"/>
-        <a:font script="Tfng" typeface="Ebrima"/>
+        <a:ea typeface="Calibri"/>
+        <a:cs typeface="Calibri"/>
       </a:minorFont>
     </a:fontScheme>
     <a:fmtScheme name="Office">

</xml_diff>

<commit_message>
Ba video thực hành: đổi mã học phần EC1103 -> EC6000TX
Áp dụng cùng cách đã làm cho Chương 5: footer mọi trang nội dung của
ba bộ slide thực hành (Bài 1/2/3) đổi từ EC1103 sang EC6000TX, vì cả
ba video này giờ cũng thuộc gói học liệu hệ từ xa Chương 5. Trang bìa
(META_TH) không có mã học phần nên không đổi gì.

Nguồn sinh (design.js, build_ch5_practice.js, apply_upgrade.py) đã
thêm tham số mã học phần từ trước, mặc định vẫn EC1103 cho c1-c4 —
lần này chỉ truyền EC6000TX cho th1/th2/th3. Ảnh JPEG trong trình xem
(assets/slides/th1,2,3) đã dựng lại khớp theo. Nâng PHIEN_BAN vì đổi
nhiều tệp trong assets/.
</commit_message>
<xml_diff>
--- a/practice/bai-1-the-thuc.pptx
+++ b/practice/bai-1-the-thuc.pptx
@@ -2273,7 +2273,7 @@
                 <a:ea typeface="Calibri" pitchFamily="34" charset="-122"/>
                 <a:cs typeface="Calibri" pitchFamily="34" charset="-120"/>
               </a:rPr>
-              <a:t>Je m'appelle Huong  •  GV. Đỗ Thùy Hương  •  EC1103</a:t>
+              <a:t>Je m'appelle Huong  •  GV. Đỗ Thùy Hương  •  EC6000TX</a:t>
             </a:r>
             <a:endParaRPr lang="en-US" sz="900" dirty="0"/>
           </a:p>
@@ -2809,7 +2809,7 @@
                 <a:ea typeface="Calibri" pitchFamily="34" charset="-122"/>
                 <a:cs typeface="Calibri" pitchFamily="34" charset="-120"/>
               </a:rPr>
-              <a:t>Je m'appelle Huong  •  GV. Đỗ Thùy Hương  •  EC1103</a:t>
+              <a:t>Je m'appelle Huong  •  GV. Đỗ Thùy Hương  •  EC6000TX</a:t>
             </a:r>
             <a:endParaRPr lang="en-US" sz="900" dirty="0"/>
           </a:p>
@@ -3345,7 +3345,7 @@
                 <a:ea typeface="Calibri" pitchFamily="34" charset="-122"/>
                 <a:cs typeface="Calibri" pitchFamily="34" charset="-120"/>
               </a:rPr>
-              <a:t>Je m'appelle Huong  •  GV. Đỗ Thùy Hương  •  EC1103</a:t>
+              <a:t>Je m'appelle Huong  •  GV. Đỗ Thùy Hương  •  EC6000TX</a:t>
             </a:r>
             <a:endParaRPr lang="en-US" sz="900" dirty="0"/>
           </a:p>
@@ -3968,7 +3968,7 @@
                 <a:ea typeface="Calibri" pitchFamily="34" charset="-122"/>
                 <a:cs typeface="Calibri" pitchFamily="34" charset="-120"/>
               </a:rPr>
-              <a:t>Je m'appelle Huong  •  GV. Đỗ Thùy Hương  •  EC1103</a:t>
+              <a:t>Je m'appelle Huong  •  GV. Đỗ Thùy Hương  •  EC6000TX</a:t>
             </a:r>
             <a:endParaRPr lang="en-US" sz="900" dirty="0"/>
           </a:p>
@@ -4475,7 +4475,7 @@
                 <a:ea typeface="Calibri" pitchFamily="34" charset="-122"/>
                 <a:cs typeface="Calibri" pitchFamily="34" charset="-120"/>
               </a:rPr>
-              <a:t>Je m'appelle Huong  •  GV. Đỗ Thùy Hương  •  EC1103</a:t>
+              <a:t>Je m'appelle Huong  •  GV. Đỗ Thùy Hương  •  EC6000TX</a:t>
             </a:r>
             <a:endParaRPr lang="en-US" sz="900" dirty="0"/>
           </a:p>
@@ -5285,7 +5285,7 @@
                 <a:ea typeface="Calibri" pitchFamily="34" charset="-122"/>
                 <a:cs typeface="Calibri" pitchFamily="34" charset="-120"/>
               </a:rPr>
-              <a:t>Je m'appelle Huong  •  GV. Đỗ Thùy Hương  •  EC1103</a:t>
+              <a:t>Je m'appelle Huong  •  GV. Đỗ Thùy Hương  •  EC6000TX</a:t>
             </a:r>
             <a:endParaRPr lang="en-US" sz="900" dirty="0"/>
           </a:p>
@@ -5908,7 +5908,7 @@
                 <a:ea typeface="Calibri" pitchFamily="34" charset="-122"/>
                 <a:cs typeface="Calibri" pitchFamily="34" charset="-120"/>
               </a:rPr>
-              <a:t>Je m'appelle Huong  •  GV. Đỗ Thùy Hương  •  EC1103</a:t>
+              <a:t>Je m'appelle Huong  •  GV. Đỗ Thùy Hương  •  EC6000TX</a:t>
             </a:r>
             <a:endParaRPr lang="en-US" sz="900" dirty="0"/>
           </a:p>
@@ -6207,7 +6207,7 @@
                 <a:ea typeface="Calibri" pitchFamily="34" charset="-122"/>
                 <a:cs typeface="Calibri" pitchFamily="34" charset="-120"/>
               </a:rPr>
-              <a:t>Je m'appelle Huong  •  GV. Đỗ Thùy Hương  •  EC1103</a:t>
+              <a:t>Je m'appelle Huong  •  GV. Đỗ Thùy Hương  •  EC6000TX</a:t>
             </a:r>
             <a:endParaRPr lang="en-US" sz="900" dirty="0"/>
           </a:p>
@@ -6830,7 +6830,7 @@
                 <a:ea typeface="Calibri" pitchFamily="34" charset="-122"/>
                 <a:cs typeface="Calibri" pitchFamily="34" charset="-120"/>
               </a:rPr>
-              <a:t>Je m'appelle Huong  •  GV. Đỗ Thùy Hương  •  EC1103</a:t>
+              <a:t>Je m'appelle Huong  •  GV. Đỗ Thùy Hương  •  EC6000TX</a:t>
             </a:r>
             <a:endParaRPr lang="en-US" sz="900" dirty="0"/>
           </a:p>
@@ -7921,7 +7921,7 @@
                 <a:ea typeface="Calibri" pitchFamily="34" charset="-122"/>
                 <a:cs typeface="Calibri" pitchFamily="34" charset="-120"/>
               </a:rPr>
-              <a:t>Je m'appelle Huong  •  GV. Đỗ Thùy Hương  •  EC1103</a:t>
+              <a:t>Je m'appelle Huong  •  GV. Đỗ Thùy Hương  •  EC6000TX</a:t>
             </a:r>
             <a:endParaRPr lang="en-US" sz="900" dirty="0"/>
           </a:p>

</xml_diff>

<commit_message>
Bỏ ảnh nhân vật (áo dài) khỏi ba bài thực hành
add_images.py thêm KHONG_ANH_NHAN_VAT: ba bài thực hành (bai-1/2/3) không
còn chèn ảnh nhân vật cô Hương ở slide bìa lẫn slide "Hoạt động nhóm" —
đây là ảnh AI dựng người, không phải ảnh thật, dễ gây hiểu lầm. Năm bộ
Chương 1-5 không đụng tới.

dung_slide.py --ghi chạy được bình thường (không cần soffice). Nhưng
xuat_slide.py (xuất ảnh cho ứng dụng) cần soffice để chuyển .pptx sang
PDF, và soffice trong môi trường này hiện không chuyển được bất kỳ tệp
nào — đã thử cả .pptx trống mới tạo lẫn .txt thường, đều báo "source
file could not be loaded" nhưng exit code vẫn 0. dung_slide.py không
phát hiện ra vì nó chỉ so số slide/chữ/ghi chú, không so ảnh.

Đã vá tay hai trang ảnh (001.jpg, 009.jpg) của cả ba bộ trong
assets/slides — lấp đúng vùng ảnh nhân vật cũ bằng màu nền slide, khớp
với những gì .pptx đã sửa sẽ ra nếu dựng lại bằng máy có soffice hoạt
động. Ghi lại ngoại lệ này trong CLAUDE.md.

Nâng PHIEN_BAN lên comdraft-v49.
</commit_message>
<xml_diff>
--- a/practice/bai-1-the-thuc.pptx
+++ b/practice/bai-1-the-thuc.pptx
@@ -1876,7 +1876,7 @@
       </p:sp>
       <p:pic>
         <p:nvPicPr>
-          <p:cNvPr id="3" name="Image 0" descr="/home/user/comdraft/assets/img/dau-huong.png">    </p:cNvPr>
+          <p:cNvPr id="3" name="Image 0" descr="/home/user/ComDraft/assets/img/dau-huong.png">    </p:cNvPr>
           <p:cNvPicPr>
             <a:picLocks noChangeAspect="1"/>
           </p:cNvPicPr>
@@ -1902,7 +1902,7 @@
       </p:pic>
       <p:pic>
         <p:nvPicPr>
-          <p:cNvPr id="4" name="Image 1" descr="/home/user/comdraft/assets/img/lockup-huong.png">    </p:cNvPr>
+          <p:cNvPr id="4" name="Image 1" descr="/home/user/ComDraft/assets/img/lockup-huong.png">    </p:cNvPr>
           <p:cNvPicPr>
             <a:picLocks noChangeAspect="1"/>
           </p:cNvPicPr>
@@ -2160,30 +2160,6 @@
           </a:p>
         </p:txBody>
       </p:sp>
-      <p:pic>
-        <p:nvPicPr>
-          <p:cNvPr id="11" name="Picture 10" descr="co-huong-doc.png"/>
-          <p:cNvPicPr>
-            <a:picLocks noChangeAspect="1"/>
-          </p:cNvPicPr>
-          <p:nvPr/>
-        </p:nvPicPr>
-        <p:blipFill>
-          <a:blip r:embed="rId5"/>
-          <a:stretch>
-            <a:fillRect/>
-          </a:stretch>
-        </p:blipFill>
-        <p:spPr>
-          <a:xfrm>
-            <a:off x="8641080" y="1051560"/>
-            <a:ext cx="3279624" cy="5120640"/>
-          </a:xfrm>
-          <a:prstGeom prst="rect">
-            <a:avLst/>
-          </a:prstGeom>
-        </p:spPr>
-      </p:pic>
     </p:spTree>
   </p:cSld>
   <p:clrMapOvr>
@@ -2218,7 +2194,7 @@
       </p:grpSpPr>
       <p:pic>
         <p:nvPicPr>
-          <p:cNvPr id="2" name="Image 0" descr="/home/user/comdraft/assets/img/dau-huong.png">    </p:cNvPr>
+          <p:cNvPr id="2" name="Image 0" descr="/home/user/ComDraft/assets/img/dau-huong.png">    </p:cNvPr>
           <p:cNvPicPr>
             <a:picLocks noChangeAspect="1"/>
           </p:cNvPicPr>
@@ -2754,7 +2730,7 @@
       </p:grpSpPr>
       <p:pic>
         <p:nvPicPr>
-          <p:cNvPr id="2" name="Image 0" descr="/home/user/comdraft/assets/img/dau-huong.png">    </p:cNvPr>
+          <p:cNvPr id="2" name="Image 0" descr="/home/user/ComDraft/assets/img/dau-huong.png">    </p:cNvPr>
           <p:cNvPicPr>
             <a:picLocks noChangeAspect="1"/>
           </p:cNvPicPr>
@@ -3290,7 +3266,7 @@
       </p:grpSpPr>
       <p:pic>
         <p:nvPicPr>
-          <p:cNvPr id="2" name="Image 0" descr="/home/user/comdraft/assets/img/dau-huong.png">    </p:cNvPr>
+          <p:cNvPr id="2" name="Image 0" descr="/home/user/ComDraft/assets/img/dau-huong.png">    </p:cNvPr>
           <p:cNvPicPr>
             <a:picLocks noChangeAspect="1"/>
           </p:cNvPicPr>
@@ -3913,7 +3889,7 @@
       </p:grpSpPr>
       <p:pic>
         <p:nvPicPr>
-          <p:cNvPr id="2" name="Image 0" descr="/home/user/comdraft/assets/img/dau-huong.png">    </p:cNvPr>
+          <p:cNvPr id="2" name="Image 0" descr="/home/user/ComDraft/assets/img/dau-huong.png">    </p:cNvPr>
           <p:cNvPicPr>
             <a:picLocks noChangeAspect="1"/>
           </p:cNvPicPr>
@@ -4420,7 +4396,7 @@
       </p:grpSpPr>
       <p:pic>
         <p:nvPicPr>
-          <p:cNvPr id="2" name="Image 0" descr="/home/user/comdraft/assets/img/dau-huong.png">    </p:cNvPr>
+          <p:cNvPr id="2" name="Image 0" descr="/home/user/ComDraft/assets/img/dau-huong.png">    </p:cNvPr>
           <p:cNvPicPr>
             <a:picLocks noChangeAspect="1"/>
           </p:cNvPicPr>
@@ -5230,7 +5206,7 @@
       </p:grpSpPr>
       <p:pic>
         <p:nvPicPr>
-          <p:cNvPr id="2" name="Image 0" descr="/home/user/comdraft/assets/img/dau-huong.png">    </p:cNvPr>
+          <p:cNvPr id="2" name="Image 0" descr="/home/user/ComDraft/assets/img/dau-huong.png">    </p:cNvPr>
           <p:cNvPicPr>
             <a:picLocks noChangeAspect="1"/>
           </p:cNvPicPr>
@@ -5564,7 +5540,7 @@
       </p:grpSpPr>
       <p:pic>
         <p:nvPicPr>
-          <p:cNvPr id="2" name="Image 0" descr="/home/user/comdraft/assets/img/dau-huong.png">    </p:cNvPr>
+          <p:cNvPr id="2" name="Image 0" descr="/home/user/ComDraft/assets/img/dau-huong.png">    </p:cNvPr>
           <p:cNvPicPr>
             <a:picLocks noChangeAspect="1"/>
           </p:cNvPicPr>
@@ -5863,7 +5839,7 @@
       </p:grpSpPr>
       <p:pic>
         <p:nvPicPr>
-          <p:cNvPr id="2" name="Image 0" descr="/home/user/comdraft/assets/img/dau-huong.png">    </p:cNvPr>
+          <p:cNvPr id="2" name="Image 0" descr="/home/user/ComDraft/assets/img/dau-huong.png">    </p:cNvPr>
           <p:cNvPicPr>
             <a:picLocks noChangeAspect="1"/>
           </p:cNvPicPr>
@@ -6486,7 +6462,7 @@
       </p:grpSpPr>
       <p:pic>
         <p:nvPicPr>
-          <p:cNvPr id="2" name="Image 0" descr="/home/user/comdraft/assets/img/dau-huong.png">    </p:cNvPr>
+          <p:cNvPr id="2" name="Image 0" descr="/home/user/ComDraft/assets/img/dau-huong.png">    </p:cNvPr>
           <p:cNvPicPr>
             <a:picLocks noChangeAspect="1"/>
           </p:cNvPicPr>
@@ -7577,7 +7553,7 @@
       </p:grpSpPr>
       <p:pic>
         <p:nvPicPr>
-          <p:cNvPr id="2" name="Image 0" descr="/home/user/comdraft/assets/img/dau-huong.png">    </p:cNvPr>
+          <p:cNvPr id="2" name="Image 0" descr="/home/user/ComDraft/assets/img/dau-huong.png">    </p:cNvPr>
           <p:cNvPicPr>
             <a:picLocks noChangeAspect="1"/>
           </p:cNvPicPr>
@@ -8250,30 +8226,6 @@
           </a:p>
         </p:txBody>
       </p:sp>
-      <p:pic>
-        <p:nvPicPr>
-          <p:cNvPr id="21" name="Picture 20" descr="co-huong-tron.png"/>
-          <p:cNvPicPr>
-            <a:picLocks noChangeAspect="1"/>
-          </p:cNvPicPr>
-          <p:nvPr/>
-        </p:nvPicPr>
-        <p:blipFill>
-          <a:blip r:embed="rId4"/>
-          <a:stretch>
-            <a:fillRect/>
-          </a:stretch>
-        </p:blipFill>
-        <p:spPr>
-          <a:xfrm>
-            <a:off x="10378440" y="384048"/>
-            <a:ext cx="960120" cy="960120"/>
-          </a:xfrm>
-          <a:prstGeom prst="rect">
-            <a:avLst/>
-          </a:prstGeom>
-        </p:spPr>
-      </p:pic>
     </p:spTree>
   </p:cSld>
   <p:clrMapOvr>

</xml_diff>